<commit_message>
월 시딩 건수 5의 배수로 정리(마이크로 15/35/20/15/30/35, 나노 20/45/25/20/30/35, 총건수 45/100/55/45/80/90), 총합 유지
</commit_message>
<xml_diff>
--- a/proposal/올더베러_액션플랜_견적서_편집용.pptx
+++ b/proposal/올더베러_액션플랜_견적서_편집용.pptx
@@ -3850,13 +3850,13 @@
                           </a:solidFill>
                           <a:latin typeface="맑은 고딕"/>
                         </a:rPr>
-                        <a:t>18</a:t>
-                      </a:r>
-                    </a:p>
-                  </a:txBody>
-                  <a:tcPr marL="50800" marR="50800" marT="12700" marB="12700" anchor="ctr">
-                    <a:solidFill>
-                      <a:srgbClr val="A9A9A9"/>
+                        <a:t>15</a:t>
+                      </a:r>
+                    </a:p>
+                  </a:txBody>
+                  <a:tcPr marL="50800" marR="50800" marT="12700" marB="12700" anchor="ctr">
+                    <a:solidFill>
+                      <a:srgbClr val="B7B7B7"/>
                     </a:solidFill>
                   </a:tcPr>
                 </a:tc>
@@ -3919,13 +3919,13 @@
                           </a:solidFill>
                           <a:latin typeface="맑은 고딕"/>
                         </a:rPr>
-                        <a:t>17</a:t>
-                      </a:r>
-                    </a:p>
-                  </a:txBody>
-                  <a:tcPr marL="50800" marR="50800" marT="12700" marB="12700" anchor="ctr">
-                    <a:solidFill>
-                      <a:srgbClr val="AEAEAE"/>
+                        <a:t>15</a:t>
+                      </a:r>
+                    </a:p>
+                  </a:txBody>
+                  <a:tcPr marL="50800" marR="50800" marT="12700" marB="12700" anchor="ctr">
+                    <a:solidFill>
+                      <a:srgbClr val="B7B7B7"/>
                     </a:solidFill>
                   </a:tcPr>
                 </a:tc>
@@ -3942,13 +3942,13 @@
                           </a:solidFill>
                           <a:latin typeface="맑은 고딕"/>
                         </a:rPr>
-                        <a:t>28</a:t>
-                      </a:r>
-                    </a:p>
-                  </a:txBody>
-                  <a:tcPr marL="50800" marR="50800" marT="12700" marB="12700" anchor="ctr">
-                    <a:solidFill>
-                      <a:srgbClr val="797979"/>
+                        <a:t>30</a:t>
+                      </a:r>
+                    </a:p>
+                  </a:txBody>
+                  <a:tcPr marL="50800" marR="50800" marT="12700" marB="12700" anchor="ctr">
+                    <a:solidFill>
+                      <a:srgbClr val="6F6F6F"/>
                     </a:solidFill>
                   </a:tcPr>
                 </a:tc>
@@ -3965,13 +3965,13 @@
                           </a:solidFill>
                           <a:latin typeface="맑은 고딕"/>
                         </a:rPr>
-                        <a:t>32</a:t>
-                      </a:r>
-                    </a:p>
-                  </a:txBody>
-                  <a:tcPr marL="50800" marR="50800" marT="12700" marB="12700" anchor="ctr">
-                    <a:solidFill>
-                      <a:srgbClr val="666666"/>
+                        <a:t>35</a:t>
+                      </a:r>
+                    </a:p>
+                  </a:txBody>
+                  <a:tcPr marL="50800" marR="50800" marT="12700" marB="12700" anchor="ctr">
+                    <a:solidFill>
+                      <a:srgbClr val="575757"/>
                     </a:solidFill>
                   </a:tcPr>
                 </a:tc>
@@ -4048,13 +4048,13 @@
                           </a:solidFill>
                           <a:latin typeface="맑은 고딕"/>
                         </a:rPr>
-                        <a:t>22</a:t>
-                      </a:r>
-                    </a:p>
-                  </a:txBody>
-                  <a:tcPr marL="50800" marR="50800" marT="12700" marB="12700" anchor="ctr">
-                    <a:solidFill>
-                      <a:srgbClr val="A7A7A7"/>
+                        <a:t>20</a:t>
+                      </a:r>
+                    </a:p>
+                  </a:txBody>
+                  <a:tcPr marL="50800" marR="50800" marT="12700" marB="12700" anchor="ctr">
+                    <a:solidFill>
+                      <a:srgbClr val="B5B5B5"/>
                     </a:solidFill>
                   </a:tcPr>
                 </a:tc>
@@ -4071,7 +4071,7 @@
                           </a:solidFill>
                           <a:latin typeface="맑은 고딕"/>
                         </a:rPr>
-                        <a:t>42</a:t>
+                        <a:t>45</a:t>
                       </a:r>
                     </a:p>
                   </a:txBody>
@@ -4100,7 +4100,7 @@
                   </a:txBody>
                   <a:tcPr marL="50800" marR="50800" marT="12700" marB="12700" anchor="ctr">
                     <a:solidFill>
-                      <a:srgbClr val="9B9B9B"/>
+                      <a:srgbClr val="A2A2A2"/>
                     </a:solidFill>
                   </a:tcPr>
                 </a:tc>
@@ -4123,7 +4123,7 @@
                   </a:txBody>
                   <a:tcPr marL="50800" marR="50800" marT="12700" marB="12700" anchor="ctr">
                     <a:solidFill>
-                      <a:srgbClr val="AFAFAF"/>
+                      <a:srgbClr val="B5B5B5"/>
                     </a:solidFill>
                   </a:tcPr>
                 </a:tc>
@@ -4146,7 +4146,7 @@
                   </a:txBody>
                   <a:tcPr marL="50800" marR="50800" marT="12700" marB="12700" anchor="ctr">
                     <a:solidFill>
-                      <a:srgbClr val="878787"/>
+                      <a:srgbClr val="8F8F8F"/>
                     </a:solidFill>
                   </a:tcPr>
                 </a:tc>
@@ -4163,13 +4163,13 @@
                           </a:solidFill>
                           <a:latin typeface="맑은 고딕"/>
                         </a:rPr>
-                        <a:t>36</a:t>
-                      </a:r>
-                    </a:p>
-                  </a:txBody>
-                  <a:tcPr marL="50800" marR="50800" marT="12700" marB="12700" anchor="ctr">
-                    <a:solidFill>
-                      <a:srgbClr val="6F6F6F"/>
+                        <a:t>35</a:t>
+                      </a:r>
+                    </a:p>
+                  </a:txBody>
+                  <a:tcPr marL="50800" marR="50800" marT="12700" marB="12700" anchor="ctr">
+                    <a:solidFill>
+                      <a:srgbClr val="7D7D7D"/>
                     </a:solidFill>
                   </a:tcPr>
                 </a:tc>
@@ -6049,7 +6049,7 @@
                           </a:solidFill>
                           <a:latin typeface="맑은 고딕"/>
                         </a:rPr>
-                        <a:t>50</a:t>
+                        <a:t>45</a:t>
                       </a:r>
                     </a:p>
                   </a:txBody>
@@ -6072,7 +6072,7 @@
                           </a:solidFill>
                           <a:latin typeface="맑은 고딕"/>
                         </a:rPr>
-                        <a:t>97</a:t>
+                        <a:t>100</a:t>
                       </a:r>
                     </a:p>
                   </a:txBody>
@@ -6118,7 +6118,7 @@
                           </a:solidFill>
                           <a:latin typeface="맑은 고딕"/>
                         </a:rPr>
-                        <a:t>47</a:t>
+                        <a:t>45</a:t>
                       </a:r>
                     </a:p>
                   </a:txBody>
@@ -6141,7 +6141,7 @@
                           </a:solidFill>
                           <a:latin typeface="맑은 고딕"/>
                         </a:rPr>
-                        <a:t>78</a:t>
+                        <a:t>80</a:t>
                       </a:r>
                     </a:p>
                   </a:txBody>
@@ -6164,7 +6164,7 @@
                           </a:solidFill>
                           <a:latin typeface="맑은 고딕"/>
                         </a:rPr>
-                        <a:t>88</a:t>
+                        <a:t>90</a:t>
                       </a:r>
                     </a:p>
                   </a:txBody>

</xml_diff>